<commit_message>
Review deck: fix rendering + add training/honesty slide (16 slides)
- slide 5 (LIF steps): captions no longer clipped (step images taller + 2x
  supersampled for crisp embedding)
- datapath / model diagrams re-rendered at 300 dpi (sharper)
- new slide "How it learns, and how good it really is": offline
  quantisation-aware surrogate-gradient training, and the honest caveat that the
  99.7% is on synthetic (too-separable) data with real-dataset results to come

Co-Authored-By: Claude Opus 4.8 <noreply@anthropic.com>
</commit_message>
<xml_diff>
--- a/docs/SNN_Neuron_Review.pptx
+++ b/docs/SNN_Neuron_Review.pptx
@@ -20,6 +20,7 @@
     <p:sldId id="268" r:id="rId20"/>
     <p:sldId id="269" r:id="rId21"/>
     <p:sldId id="270" r:id="rId22"/>
+    <p:sldId id="271" r:id="rId23"/>
   </p:sldIdLst>
   <p:sldSz cx="12191695" cy="6858000" type="screen4x3"/>
   <p:notesSz cx="6858000" cy="9144000"/>
@@ -1130,6 +1131,76 @@
 </file>
 
 <file path=ppt/notesSlides/notesSlide15.xml><?xml version="1.0" encoding="utf-8"?>
+<p:notes xmlns:a="http://schemas.openxmlformats.org/drawingml/2006/main" xmlns:p="http://schemas.openxmlformats.org/presentationml/2006/main" xmlns:r="http://schemas.openxmlformats.org/officeDocument/2006/relationships">
+  <p:cSld>
+    <p:spTree>
+      <p:nvGrpSpPr>
+        <p:cNvPr id="1" name=""/>
+        <p:cNvGrpSpPr/>
+        <p:nvPr/>
+      </p:nvGrpSpPr>
+      <p:grpSpPr>
+        <a:xfrm>
+          <a:off x="0" y="0"/>
+          <a:ext cx="0" cy="0"/>
+          <a:chOff x="0" y="0"/>
+          <a:chExt cx="0" cy="0"/>
+        </a:xfrm>
+      </p:grpSpPr>
+      <p:sp>
+        <p:nvSpPr>
+          <p:cNvPr id="2" name="Slide Image Placeholder 1"/>
+          <p:cNvSpPr>
+            <a:spLocks noGrp="1"/>
+          </p:cNvSpPr>
+          <p:nvPr>
+            <p:ph type="sldImg" idx="2"/>
+          </p:nvPr>
+        </p:nvSpPr>
+        <p:spPr/>
+      </p:sp>
+      <p:sp>
+        <p:nvSpPr>
+          <p:cNvPr id="3" name="Notes Placeholder 2"/>
+          <p:cNvSpPr>
+            <a:spLocks noGrp="1"/>
+          </p:cNvSpPr>
+          <p:nvPr>
+            <p:ph type="body" idx="3" sz="quarter"/>
+          </p:nvPr>
+        </p:nvSpPr>
+        <p:spPr/>
+        <p:txBody>
+          <a:bodyPr/>
+          <a:lstStyle/>
+          <a:p>
+            <a:r>
+              <a:t>A reviewer will ask how the weights are found and how good it really is. The weights are learned offline in PyTorch with surrogate gradients, quantisation-aware so the int8 weights run bit-exactly on the chip. The honest caveat: results so far are on synthetic traffic, which is realistic per packet but too cleanly separable, so the headline accuracy is an upper bound; real datasets come next.</a:t>
+            </a:r>
+          </a:p>
+        </p:txBody>
+      </p:sp>
+      <p:sp>
+        <p:nvSpPr>
+          <p:cNvPr id="4" name="Slide Number Placeholder 3"/>
+          <p:cNvSpPr>
+            <a:spLocks noGrp="1"/>
+          </p:cNvSpPr>
+          <p:nvPr>
+            <p:ph type="sldNum" idx="5" sz="quarter"/>
+          </p:nvPr>
+        </p:nvSpPr>
+        <p:spPr/>
+      </p:sp>
+    </p:spTree>
+  </p:cSld>
+  <p:clrMapOvr>
+    <a:masterClrMapping/>
+  </p:clrMapOvr>
+</p:notes>
+</file>
+
+<file path=ppt/notesSlides/notesSlide16.xml><?xml version="1.0" encoding="utf-8"?>
 <p:notes xmlns:a="http://schemas.openxmlformats.org/drawingml/2006/main" xmlns:p="http://schemas.openxmlformats.org/presentationml/2006/main" xmlns:r="http://schemas.openxmlformats.org/officeDocument/2006/relationships">
   <p:cSld>
     <p:spTree>
@@ -5446,7 +5517,7 @@
         <p:spPr>
           <a:xfrm>
             <a:off x="457200" y="1463040"/>
-            <a:ext cx="5577840" cy="1640974"/>
+            <a:ext cx="5577840" cy="1643072"/>
           </a:xfrm>
           <a:prstGeom prst="rect">
             <a:avLst/>
@@ -5470,7 +5541,7 @@
         <p:spPr>
           <a:xfrm>
             <a:off x="6126480" y="1463040"/>
-            <a:ext cx="5577840" cy="1640974"/>
+            <a:ext cx="5577840" cy="1643072"/>
           </a:xfrm>
           <a:prstGeom prst="rect">
             <a:avLst/>
@@ -5494,7 +5565,7 @@
         <p:spPr>
           <a:xfrm>
             <a:off x="457200" y="3566160"/>
-            <a:ext cx="6766560" cy="2173690"/>
+            <a:ext cx="6766560" cy="2174966"/>
           </a:xfrm>
           <a:prstGeom prst="rect">
             <a:avLst/>
@@ -11158,6 +11229,551 @@
     <p:bg>
       <p:bgPr>
         <a:solidFill>
+          <a:srgbClr val="FFFFFF"/>
+        </a:solidFill>
+        <a:effectLst/>
+      </p:bgPr>
+    </p:bg>
+    <p:spTree>
+      <p:nvGrpSpPr>
+        <p:cNvPr id="1" name=""/>
+        <p:cNvGrpSpPr/>
+        <p:nvPr/>
+      </p:nvGrpSpPr>
+      <p:grpSpPr/>
+      <p:sp>
+        <p:nvSpPr>
+          <p:cNvPr id="2" name="TextBox 1"/>
+          <p:cNvSpPr txBox="1"/>
+          <p:nvPr/>
+        </p:nvSpPr>
+        <p:spPr>
+          <a:xfrm>
+            <a:off x="11002975" y="6400800"/>
+            <a:ext cx="822960" cy="274320"/>
+          </a:xfrm>
+          <a:prstGeom prst="rect">
+            <a:avLst/>
+          </a:prstGeom>
+          <a:noFill/>
+        </p:spPr>
+        <p:txBody>
+          <a:bodyPr wrap="square" anchor="t" lIns="45720" rIns="45720">
+            <a:spAutoFit/>
+          </a:bodyPr>
+          <a:lstStyle/>
+          <a:p>
+            <a:pPr algn="r">
+              <a:spcAft>
+                <a:spcPts val="400"/>
+              </a:spcAft>
+            </a:pPr>
+            <a:r>
+              <a:rPr sz="1100" b="0" i="0">
+                <a:solidFill>
+                  <a:srgbClr val="5F6F78"/>
+                </a:solidFill>
+                <a:latin typeface="Calibri"/>
+              </a:rPr>
+              <a:t>15</a:t>
+            </a:r>
+          </a:p>
+        </p:txBody>
+      </p:sp>
+      <p:sp>
+        <p:nvSpPr>
+          <p:cNvPr id="3" name="Title"/>
+          <p:cNvSpPr txBox="1"/>
+          <p:nvPr/>
+        </p:nvSpPr>
+        <p:spPr>
+          <a:xfrm>
+            <a:off x="548640" y="320040"/>
+            <a:ext cx="11064240" cy="777240"/>
+          </a:xfrm>
+          <a:prstGeom prst="rect">
+            <a:avLst/>
+          </a:prstGeom>
+          <a:noFill/>
+        </p:spPr>
+        <p:txBody>
+          <a:bodyPr wrap="square" anchor="ctr" lIns="45720" rIns="45720">
+            <a:spAutoFit/>
+          </a:bodyPr>
+          <a:lstStyle/>
+          <a:p>
+            <a:pPr algn="l">
+              <a:spcAft>
+                <a:spcPts val="400"/>
+              </a:spcAft>
+            </a:pPr>
+            <a:r>
+              <a:rPr sz="3400" b="1" i="0">
+                <a:solidFill>
+                  <a:srgbClr val="0F2A33"/>
+                </a:solidFill>
+                <a:latin typeface="Cambria"/>
+              </a:rPr>
+              <a:t>How it learns, and how good it really is</a:t>
+            </a:r>
+          </a:p>
+        </p:txBody>
+      </p:sp>
+      <p:sp>
+        <p:nvSpPr>
+          <p:cNvPr id="4" name="Rounded Rectangle 3"/>
+          <p:cNvSpPr/>
+          <p:nvPr/>
+        </p:nvSpPr>
+        <p:spPr>
+          <a:xfrm>
+            <a:off x="548640" y="1554480"/>
+            <a:ext cx="5486400" cy="4572000"/>
+          </a:xfrm>
+          <a:prstGeom prst="roundRect">
+            <a:avLst>
+              <a:gd name="adj" fmla="val 12000"/>
+            </a:avLst>
+          </a:prstGeom>
+          <a:solidFill>
+            <a:srgbClr val="EAF2F3"/>
+          </a:solidFill>
+          <a:ln>
+            <a:noFill/>
+          </a:ln>
+          <a:effectLst/>
+        </p:spPr>
+        <p:style>
+          <a:lnRef idx="1">
+            <a:schemeClr val="accent1"/>
+          </a:lnRef>
+          <a:fillRef idx="3">
+            <a:schemeClr val="accent1"/>
+          </a:fillRef>
+          <a:effectRef idx="2">
+            <a:schemeClr val="accent1"/>
+          </a:effectRef>
+          <a:fontRef idx="minor">
+            <a:schemeClr val="lt1"/>
+          </a:fontRef>
+        </p:style>
+        <p:txBody>
+          <a:bodyPr rtlCol="0" anchor="ctr" wrap="square" lIns="73152" rIns="73152" tIns="73152" bIns="73152"/>
+          <a:lstStyle/>
+          <a:p>
+            <a:pPr algn="ctr"/>
+          </a:p>
+        </p:txBody>
+      </p:sp>
+      <p:sp>
+        <p:nvSpPr>
+          <p:cNvPr id="5" name="TextBox 4"/>
+          <p:cNvSpPr txBox="1"/>
+          <p:nvPr/>
+        </p:nvSpPr>
+        <p:spPr>
+          <a:xfrm>
+            <a:off x="822960" y="1737360"/>
+            <a:ext cx="4937760" cy="457200"/>
+          </a:xfrm>
+          <a:prstGeom prst="rect">
+            <a:avLst/>
+          </a:prstGeom>
+          <a:noFill/>
+        </p:spPr>
+        <p:txBody>
+          <a:bodyPr wrap="square" anchor="t" lIns="45720" rIns="45720">
+            <a:spAutoFit/>
+          </a:bodyPr>
+          <a:lstStyle/>
+          <a:p>
+            <a:pPr algn="l">
+              <a:spcAft>
+                <a:spcPts val="400"/>
+              </a:spcAft>
+            </a:pPr>
+            <a:r>
+              <a:rPr sz="1900" b="1" i="0">
+                <a:solidFill>
+                  <a:srgbClr val="2E86AB"/>
+                </a:solidFill>
+                <a:latin typeface="Cambria"/>
+              </a:rPr>
+              <a:t>Training (offline, in PyTorch)</a:t>
+            </a:r>
+          </a:p>
+        </p:txBody>
+      </p:sp>
+      <p:sp>
+        <p:nvSpPr>
+          <p:cNvPr id="6" name="TextBox 5"/>
+          <p:cNvSpPr txBox="1"/>
+          <p:nvPr/>
+        </p:nvSpPr>
+        <p:spPr>
+          <a:xfrm>
+            <a:off x="822960" y="2377440"/>
+            <a:ext cx="4937760" cy="3657600"/>
+          </a:xfrm>
+          <a:prstGeom prst="rect">
+            <a:avLst/>
+          </a:prstGeom>
+          <a:noFill/>
+        </p:spPr>
+        <p:txBody>
+          <a:bodyPr wrap="square" lIns="45720" rIns="45720">
+            <a:spAutoFit/>
+          </a:bodyPr>
+          <a:lstStyle/>
+          <a:p>
+            <a:pPr algn="l" marL="274320" indent="-219456">
+              <a:spcAft>
+                <a:spcPts val="800"/>
+              </a:spcAft>
+              <a:buClr>
+                <a:srgbClr val="F2A541"/>
+              </a:buClr>
+              <a:buChar char="•"/>
+            </a:pPr>
+            <a:r>
+              <a:rPr sz="1400" b="1" i="0">
+                <a:solidFill>
+                  <a:srgbClr val="0F2A33"/>
+                </a:solidFill>
+                <a:latin typeface="Calibri"/>
+              </a:rPr>
+              <a:t>Only the weights are learned </a:t>
+            </a:r>
+            <a:r>
+              <a:rPr sz="1400" b="0" i="0">
+                <a:solidFill>
+                  <a:srgbClr val="0F2A33"/>
+                </a:solidFill>
+                <a:latin typeface="Calibri"/>
+              </a:rPr>
+              <a:t>(int8: W1 64×16, W2 16×2, B2) — ~1.1 KB</a:t>
+            </a:r>
+          </a:p>
+          <a:p>
+            <a:pPr algn="l" marL="274320" indent="-219456">
+              <a:spcAft>
+                <a:spcPts val="800"/>
+              </a:spcAft>
+              <a:buClr>
+                <a:srgbClr val="F2A541"/>
+              </a:buClr>
+              <a:buChar char="•"/>
+            </a:pPr>
+            <a:r>
+              <a:rPr sz="1400" b="1" i="0">
+                <a:solidFill>
+                  <a:srgbClr val="0F2A33"/>
+                </a:solidFill>
+                <a:latin typeface="Calibri"/>
+              </a:rPr>
+              <a:t>Surrogate-gradient </a:t>
+            </a:r>
+            <a:r>
+              <a:rPr sz="1400" b="0" i="0">
+                <a:solidFill>
+                  <a:srgbClr val="0F2A33"/>
+                </a:solidFill>
+                <a:latin typeface="Calibri"/>
+              </a:rPr>
+              <a:t>back-prop (spikes have no gradient) [Neftci, IEEE SPM 2019]</a:t>
+            </a:r>
+          </a:p>
+          <a:p>
+            <a:pPr algn="l" marL="274320" indent="-219456">
+              <a:spcAft>
+                <a:spcPts val="800"/>
+              </a:spcAft>
+              <a:buClr>
+                <a:srgbClr val="F2A541"/>
+              </a:buClr>
+              <a:buChar char="•"/>
+            </a:pPr>
+            <a:r>
+              <a:rPr sz="1400" b="1" i="0">
+                <a:solidFill>
+                  <a:srgbClr val="0F2A33"/>
+                </a:solidFill>
+                <a:latin typeface="Calibri"/>
+              </a:rPr>
+              <a:t>Quantisation-aware: </a:t>
+            </a:r>
+            <a:r>
+              <a:rPr sz="1400" b="0" i="0">
+                <a:solidFill>
+                  <a:srgbClr val="0F2A33"/>
+                </a:solidFill>
+                <a:latin typeface="Calibri"/>
+              </a:rPr>
+              <a:t>the training math IS the integer hardware, so weights run bit-exactly on the chip — no accuracy lost</a:t>
+            </a:r>
+          </a:p>
+          <a:p>
+            <a:pPr algn="l" marL="274320" indent="-219456">
+              <a:spcAft>
+                <a:spcPts val="800"/>
+              </a:spcAft>
+              <a:buClr>
+                <a:srgbClr val="F2A541"/>
+              </a:buClr>
+              <a:buChar char="•"/>
+            </a:pPr>
+            <a:r>
+              <a:rPr sz="1400" b="1" i="0">
+                <a:solidFill>
+                  <a:srgbClr val="0F2A33"/>
+                </a:solidFill>
+                <a:latin typeface="Calibri"/>
+              </a:rPr>
+              <a:t>Load at run time </a:t>
+            </a:r>
+            <a:r>
+              <a:rPr sz="1400" b="0" i="0">
+                <a:solidFill>
+                  <a:srgbClr val="0F2A33"/>
+                </a:solidFill>
+                <a:latin typeface="Calibri"/>
+              </a:rPr>
+              <a:t>(276 register writes); retrain without a new chip</a:t>
+            </a:r>
+          </a:p>
+        </p:txBody>
+      </p:sp>
+      <p:sp>
+        <p:nvSpPr>
+          <p:cNvPr id="7" name="Rounded Rectangle 6"/>
+          <p:cNvSpPr/>
+          <p:nvPr/>
+        </p:nvSpPr>
+        <p:spPr>
+          <a:xfrm>
+            <a:off x="6263640" y="1554480"/>
+            <a:ext cx="5394960" cy="4572000"/>
+          </a:xfrm>
+          <a:prstGeom prst="roundRect">
+            <a:avLst>
+              <a:gd name="adj" fmla="val 12000"/>
+            </a:avLst>
+          </a:prstGeom>
+          <a:solidFill>
+            <a:srgbClr val="FFFFFF"/>
+          </a:solidFill>
+          <a:ln w="25400">
+            <a:solidFill>
+              <a:srgbClr val="F2A541"/>
+            </a:solidFill>
+          </a:ln>
+          <a:effectLst/>
+        </p:spPr>
+        <p:style>
+          <a:lnRef idx="1">
+            <a:schemeClr val="accent1"/>
+          </a:lnRef>
+          <a:fillRef idx="3">
+            <a:schemeClr val="accent1"/>
+          </a:fillRef>
+          <a:effectRef idx="2">
+            <a:schemeClr val="accent1"/>
+          </a:effectRef>
+          <a:fontRef idx="minor">
+            <a:schemeClr val="lt1"/>
+          </a:fontRef>
+        </p:style>
+        <p:txBody>
+          <a:bodyPr rtlCol="0" anchor="ctr" wrap="square" lIns="73152" rIns="73152" tIns="73152" bIns="73152"/>
+          <a:lstStyle/>
+          <a:p>
+            <a:pPr algn="ctr"/>
+          </a:p>
+        </p:txBody>
+      </p:sp>
+      <p:sp>
+        <p:nvSpPr>
+          <p:cNvPr id="8" name="TextBox 7"/>
+          <p:cNvSpPr txBox="1"/>
+          <p:nvPr/>
+        </p:nvSpPr>
+        <p:spPr>
+          <a:xfrm>
+            <a:off x="6537960" y="1737360"/>
+            <a:ext cx="4937760" cy="457200"/>
+          </a:xfrm>
+          <a:prstGeom prst="rect">
+            <a:avLst/>
+          </a:prstGeom>
+          <a:noFill/>
+        </p:spPr>
+        <p:txBody>
+          <a:bodyPr wrap="square" anchor="t" lIns="45720" rIns="45720">
+            <a:spAutoFit/>
+          </a:bodyPr>
+          <a:lstStyle/>
+          <a:p>
+            <a:pPr algn="l">
+              <a:spcAft>
+                <a:spcPts val="400"/>
+              </a:spcAft>
+            </a:pPr>
+            <a:r>
+              <a:rPr sz="1900" b="1" i="0">
+                <a:solidFill>
+                  <a:srgbClr val="B5761A"/>
+                </a:solidFill>
+                <a:latin typeface="Cambria"/>
+              </a:rPr>
+              <a:t>Accuracy — the honest picture</a:t>
+            </a:r>
+          </a:p>
+        </p:txBody>
+      </p:sp>
+      <p:sp>
+        <p:nvSpPr>
+          <p:cNvPr id="9" name="TextBox 8"/>
+          <p:cNvSpPr txBox="1"/>
+          <p:nvPr/>
+        </p:nvSpPr>
+        <p:spPr>
+          <a:xfrm>
+            <a:off x="6537960" y="2377440"/>
+            <a:ext cx="4937760" cy="3657600"/>
+          </a:xfrm>
+          <a:prstGeom prst="rect">
+            <a:avLst/>
+          </a:prstGeom>
+          <a:noFill/>
+        </p:spPr>
+        <p:txBody>
+          <a:bodyPr wrap="square" lIns="45720" rIns="45720">
+            <a:spAutoFit/>
+          </a:bodyPr>
+          <a:lstStyle/>
+          <a:p>
+            <a:pPr algn="l" marL="274320" indent="-219456">
+              <a:spcAft>
+                <a:spcPts val="800"/>
+              </a:spcAft>
+              <a:buClr>
+                <a:srgbClr val="F2A541"/>
+              </a:buClr>
+              <a:buChar char="•"/>
+            </a:pPr>
+            <a:r>
+              <a:rPr sz="1400" b="1" i="0">
+                <a:solidFill>
+                  <a:srgbClr val="1B998B"/>
+                </a:solidFill>
+                <a:latin typeface="Calibri"/>
+              </a:rPr>
+              <a:t>99.7% </a:t>
+            </a:r>
+            <a:r>
+              <a:rPr sz="1400" b="0" i="0">
+                <a:solidFill>
+                  <a:srgbClr val="0F2A33"/>
+                </a:solidFill>
+                <a:latin typeface="Calibri"/>
+              </a:rPr>
+              <a:t>on SYNTHETIC traffic (0.19% false alarms)</a:t>
+            </a:r>
+          </a:p>
+          <a:p>
+            <a:pPr algn="l" marL="274320" indent="-219456">
+              <a:spcAft>
+                <a:spcPts val="800"/>
+              </a:spcAft>
+              <a:buClr>
+                <a:srgbClr val="F2A541"/>
+              </a:buClr>
+              <a:buChar char="•"/>
+            </a:pPr>
+            <a:r>
+              <a:rPr sz="1400" b="1" i="0">
+                <a:solidFill>
+                  <a:srgbClr val="0F2A33"/>
+                </a:solidFill>
+                <a:latin typeface="Calibri"/>
+              </a:rPr>
+              <a:t>But that is an upper bound: </a:t>
+            </a:r>
+            <a:r>
+              <a:rPr sz="1400" b="0" i="0">
+                <a:solidFill>
+                  <a:srgbClr val="0F2A33"/>
+                </a:solidFill>
+                <a:latin typeface="Calibri"/>
+              </a:rPr>
+              <a:t>synthetic data is realistic per packet yet too cleanly separable (one header field alone classifies ~89%)</a:t>
+            </a:r>
+          </a:p>
+          <a:p>
+            <a:pPr algn="l" marL="274320" indent="-219456">
+              <a:spcAft>
+                <a:spcPts val="800"/>
+              </a:spcAft>
+              <a:buClr>
+                <a:srgbClr val="F2A541"/>
+              </a:buClr>
+              <a:buChar char="•"/>
+            </a:pPr>
+            <a:r>
+              <a:rPr sz="1400" b="1" i="0">
+                <a:solidFill>
+                  <a:srgbClr val="0F2A33"/>
+                </a:solidFill>
+                <a:latin typeface="Calibri"/>
+              </a:rPr>
+              <a:t>Real datasets (UNSW-NB15, CIC-IDS2017) next; </a:t>
+            </a:r>
+            <a:r>
+              <a:rPr sz="1400" b="0" i="0">
+                <a:solidFill>
+                  <a:srgbClr val="0F2A33"/>
+                </a:solidFill>
+                <a:latin typeface="Calibri"/>
+              </a:rPr>
+              <a:t>published SNN-IDS on real data ≈ 90% [Alom &amp; Taha, IJCNN 2017]</a:t>
+            </a:r>
+          </a:p>
+          <a:p>
+            <a:pPr algn="l" marL="274320" indent="-219456">
+              <a:spcAft>
+                <a:spcPts val="800"/>
+              </a:spcAft>
+              <a:buClr>
+                <a:srgbClr val="F2A541"/>
+              </a:buClr>
+              <a:buChar char="•"/>
+            </a:pPr>
+            <a:r>
+              <a:rPr sz="1400" b="0" i="0">
+                <a:solidFill>
+                  <a:srgbClr val="0F2A33"/>
+                </a:solidFill>
+                <a:latin typeface="Calibri"/>
+              </a:rPr>
+              <a:t>Expect lower accuracy and more false positives on real traffic — stated honestly for review</a:t>
+            </a:r>
+          </a:p>
+        </p:txBody>
+      </p:sp>
+    </p:spTree>
+  </p:cSld>
+  <p:clrMapOvr>
+    <a:masterClrMapping/>
+  </p:clrMapOvr>
+</p:sld>
+</file>
+
+<file path=ppt/slides/slide16.xml><?xml version="1.0" encoding="utf-8"?>
+<p:sld xmlns:a="http://schemas.openxmlformats.org/drawingml/2006/main" xmlns:p="http://schemas.openxmlformats.org/presentationml/2006/main" xmlns:r="http://schemas.openxmlformats.org/officeDocument/2006/relationships">
+  <p:cSld>
+    <p:bg>
+      <p:bgPr>
+        <a:solidFill>
           <a:srgbClr val="0F2A33"/>
         </a:solidFill>
         <a:effectLst/>
@@ -11204,7 +11820,7 @@
                 </a:solidFill>
                 <a:latin typeface="Calibri"/>
               </a:rPr>
-              <a:t>15</a:t>
+              <a:t>16</a:t>
             </a:r>
           </a:p>
         </p:txBody>
@@ -14161,8 +14777,8 @@
         </p:blipFill>
         <p:spPr>
           <a:xfrm>
-            <a:off x="685800" y="1463040"/>
-            <a:ext cx="5486400" cy="2457450"/>
+            <a:off x="777240" y="1417320"/>
+            <a:ext cx="4846320" cy="2324256"/>
           </a:xfrm>
           <a:prstGeom prst="rect">
             <a:avLst/>
@@ -14185,8 +14801,8 @@
         </p:blipFill>
         <p:spPr>
           <a:xfrm>
-            <a:off x="6400800" y="1463040"/>
-            <a:ext cx="5486400" cy="2457450"/>
+            <a:off x="6492240" y="1417320"/>
+            <a:ext cx="4846320" cy="2324256"/>
           </a:xfrm>
           <a:prstGeom prst="rect">
             <a:avLst/>
@@ -14209,8 +14825,8 @@
         </p:blipFill>
         <p:spPr>
           <a:xfrm>
-            <a:off x="685800" y="3767328"/>
-            <a:ext cx="5486400" cy="2457450"/>
+            <a:off x="777240" y="3867912"/>
+            <a:ext cx="4846320" cy="2324256"/>
           </a:xfrm>
           <a:prstGeom prst="rect">
             <a:avLst/>
@@ -14233,8 +14849,8 @@
         </p:blipFill>
         <p:spPr>
           <a:xfrm>
-            <a:off x="6400800" y="3767328"/>
-            <a:ext cx="5486400" cy="2457450"/>
+            <a:off x="6492240" y="3867912"/>
+            <a:ext cx="4846320" cy="2324256"/>
           </a:xfrm>
           <a:prstGeom prst="rect">
             <a:avLst/>
@@ -14933,7 +15549,7 @@
         <p:spPr>
           <a:xfrm>
             <a:off x="548640" y="1371600"/>
-            <a:ext cx="11064240" cy="4641726"/>
+            <a:ext cx="11064240" cy="4640658"/>
           </a:xfrm>
           <a:prstGeom prst="rect">
             <a:avLst/>

</xml_diff>